<commit_message>
Workshop: new creative USP and teaser (two anonymous chat bubbles)
Co-Authored-By: Claude Sonnet 5.5 <noreply@anthropic.com>
Claude-Session: https://claude.ai/code/session_01MmjQUuUoAAFt56mVbb2Lw5
</commit_message>
<xml_diff>
--- a/docs/Workshop_Almau_Messenger.pptx
+++ b/docs/Workshop_Almau_Messenger.pptx
@@ -593,7 +593,7 @@
           <a:p>
             <a:r>
               <a:rPr lang="en-US" dirty="0"/>
-              <a:t>АБУЛХАИР. Наше УТП в одной фразе: для студентов AlmaU без компании мы найдём её на мероприятие анонимно, прямо в Telegram. Здесь всё по формуле: кому — студентам AlmaU, польза — компания на мероприятие, за счёт чего — анонимность и Telegram, без скачивания. От обычных анонимных чатов нас отличает связь с реальными мероприятиями: знакомство заканчивается встречей.</a:t>
+              <a:t>АБУЛХАИР. Наше УТП: мы превращаем «не с кем идти» в «идём вместе». Кому: студентам AlmaU, которым неловко идти одним. Польза: попутчик на мероприятие. За счёт чего: анонимно, прямо в Telegram, имя и номер скрыты. От обычных анонимных чатов нас отличает связь с реальными мероприятиями: знакомство заканчивается встречей.</a:t>
             </a:r>
             <a:endParaRPr lang="en-US" dirty="0"/>
           </a:p>
@@ -681,7 +681,7 @@
           <a:p>
             <a:r>
               <a:rPr lang="en-US" dirty="0"/>
-              <a:t>ХАМИД. Тизер: заголовок «В горы хочешь, а идти не с кем?», одна фраза пользы и один призыв — «Записаться в боте». На картинке логотип клуба и QR-код. Площадка — Instagram и рассылки Summit Seekers: именно оттуда к нам уже пришли 10–15 человек. Результат измеряем по ссылке с меткой.</a:t>
+              <a:t>ХАМИД. Тизер: заголовок «Тебе не с кем идти? Кому-то тоже.» Дальше мини-диалог двух анонимов: «Кто идёт один?» — «Я тоже! Идём вместе?». Призыв один: найти попутчика в боте. На картинке QR-код. Площадка — Instagram и рассылки Summit Seekers: именно оттуда к нам уже пришли 10–15 человек. Результат измеряем по ссылке с меткой.</a:t>
             </a:r>
             <a:endParaRPr lang="en-US" dirty="0"/>
           </a:p>
@@ -1316,7 +1316,7 @@
                 <a:ea typeface="Arial" pitchFamily="34" charset="-122"/>
                 <a:cs typeface="Arial" pitchFamily="34" charset="-120"/>
               </a:rPr>
-              <a:t>Тизер и УТП: найти компанию на мероприятие</a:t>
+              <a:t>Из «не с кем идти» в «идём вместе»</a:t>
             </a:r>
             <a:endParaRPr lang="en-US" sz="4400" dirty="0"/>
           </a:p>
@@ -1405,7 +1405,7 @@
                 <a:ea typeface="Calibri" pitchFamily="34" charset="-122"/>
                 <a:cs typeface="Calibri" pitchFamily="34" charset="-120"/>
               </a:rPr>
-              <a:t>Студент AlmaU, который хочет на мероприятие клуба, но ему не с кем идти</a:t>
+              <a:t>Студент AlmaU, который хочет на мероприятие клуба, но идти одному неловко</a:t>
             </a:r>
             <a:endParaRPr lang="en-US" sz="1800" dirty="0"/>
           </a:p>
@@ -1970,12 +1970,12 @@
         </p:nvSpPr>
         <p:spPr>
           <a:xfrm>
-            <a:off x="822960" y="1645920"/>
-            <a:ext cx="10515600" cy="1828800"/>
+            <a:off x="822960" y="1600200"/>
+            <a:ext cx="10515600" cy="2011680"/>
           </a:xfrm>
           <a:prstGeom prst="roundRect">
             <a:avLst>
-              <a:gd name="adj" fmla="val 7500"/>
+              <a:gd name="adj" fmla="val 6818"/>
             </a:avLst>
           </a:prstGeom>
           <a:solidFill>
@@ -1997,8 +1997,8 @@
         </p:nvSpPr>
         <p:spPr>
           <a:xfrm>
-            <a:off x="1005840" y="1783080"/>
-            <a:ext cx="10149840" cy="1554480"/>
+            <a:off x="1005840" y="1737360"/>
+            <a:ext cx="10149840" cy="1737360"/>
           </a:xfrm>
           <a:prstGeom prst="rect">
             <a:avLst/>
@@ -2037,7 +2037,7 @@
               <a:buNone/>
             </a:pPr>
             <a:r>
-              <a:rPr lang="en-US" sz="3000" dirty="0">
+              <a:rPr lang="en-US" sz="2800" dirty="0">
                 <a:solidFill>
                   <a:srgbClr val="050507"/>
                 </a:solidFill>
@@ -2045,7 +2045,7 @@
                 <a:ea typeface="Calibri" pitchFamily="34" charset="-122"/>
                 <a:cs typeface="Calibri" pitchFamily="34" charset="-120"/>
               </a:rPr>
-              <a:t>Для студентов AlmaU без компании: найдём её на мероприятие анонимно, прямо в Telegram</a:t>
+              <a:t>Превращаем «не с кем идти» в «идём вместе»: анонимно находим студенту AlmaU попутчика на мероприятие, прямо в Telegram</a:t>
             </a:r>
             <a:endParaRPr lang="en-US" sz="1800" dirty="0"/>
           </a:p>
@@ -2134,7 +2134,7 @@
                 <a:ea typeface="Calibri" pitchFamily="34" charset="-122"/>
                 <a:cs typeface="Calibri" pitchFamily="34" charset="-120"/>
               </a:rPr>
-              <a:t>Студентам AlmaU, которым не с кем идти</a:t>
+              <a:t>Студентам AlmaU, которым неловко идти одним</a:t>
             </a:r>
             <a:endParaRPr lang="en-US" sz="2200" dirty="0"/>
           </a:p>
@@ -2223,7 +2223,7 @@
                 <a:ea typeface="Calibri" pitchFamily="34" charset="-122"/>
                 <a:cs typeface="Calibri" pitchFamily="34" charset="-120"/>
               </a:rPr>
-              <a:t>Компания на мероприятие по общим интересам</a:t>
+              <a:t>Попутчик на мероприятие: из «не с кем» в «идём вместе»</a:t>
             </a:r>
             <a:endParaRPr lang="en-US" sz="2200" dirty="0"/>
           </a:p>
@@ -2312,7 +2312,7 @@
                 <a:ea typeface="Calibri" pitchFamily="34" charset="-122"/>
                 <a:cs typeface="Calibri" pitchFamily="34" charset="-120"/>
               </a:rPr>
-              <a:t>Анонимно, в Telegram, привязано к реальным мероприятиям</a:t>
+              <a:t>Анонимно, в Telegram: имя и номер скрыты, пока сами не захотите</a:t>
             </a:r>
             <a:endParaRPr lang="en-US" sz="2200" dirty="0"/>
           </a:p>
@@ -2951,7 +2951,7 @@
       </p:sp>
       <p:pic>
         <p:nvPicPr>
-          <p:cNvPr id="6" name="Картинка тизера" descr="Тизер: В горы хочешь, а идти не с кем?">    </p:cNvPr>
+          <p:cNvPr id="6" name="Картинка тизера" descr="Тизер: Тебе не с кем идти? Кому-то тоже.">    </p:cNvPr>
           <p:cNvPicPr>
             <a:picLocks noChangeAspect="1"/>
           </p:cNvPicPr>
@@ -3055,7 +3055,7 @@
                 <a:ea typeface="Calibri" pitchFamily="34" charset="-122"/>
                 <a:cs typeface="Calibri" pitchFamily="34" charset="-120"/>
               </a:rPr>
-              <a:t>В горы хочешь, а идти не с кем?</a:t>
+              <a:t>Тебе не с кем идти? Кому-то тоже.</a:t>
             </a:r>
             <a:endParaRPr lang="en-US" sz="1600" dirty="0"/>
           </a:p>
@@ -3144,7 +3144,7 @@
                 <a:ea typeface="Calibri" pitchFamily="34" charset="-122"/>
                 <a:cs typeface="Calibri" pitchFamily="34" charset="-120"/>
               </a:rPr>
-              <a:t>Найдём компанию по интересам, анонимно</a:t>
+              <a:t>Нажми «Иду»: бот найдёт попутчика, анонимно</a:t>
             </a:r>
             <a:endParaRPr lang="en-US" sz="1600" dirty="0"/>
           </a:p>
@@ -3233,7 +3233,7 @@
                 <a:ea typeface="Calibri" pitchFamily="34" charset="-122"/>
                 <a:cs typeface="Calibri" pitchFamily="34" charset="-120"/>
               </a:rPr>
-              <a:t>Логотип клуба и QR-код на бота</a:t>
+              <a:t>Мини-диалог двух анонимов: «Я тоже!»</a:t>
             </a:r>
             <a:endParaRPr lang="en-US" sz="1600" dirty="0"/>
           </a:p>
@@ -3322,7 +3322,7 @@
                 <a:ea typeface="Calibri" pitchFamily="34" charset="-122"/>
                 <a:cs typeface="Calibri" pitchFamily="34" charset="-120"/>
               </a:rPr>
-              <a:t>Записаться в боте →</a:t>
+              <a:t>Найти попутчика в боте →</a:t>
             </a:r>
             <a:endParaRPr lang="en-US" sz="1600" dirty="0"/>
           </a:p>
@@ -4803,7 +4803,7 @@
               <a:buNone/>
             </a:pPr>
             <a:r>
-              <a:rPr lang="en-US" sz="2000" dirty="0">
+              <a:rPr lang="en-US" sz="1800" dirty="0">
                 <a:solidFill>
                   <a:srgbClr val="050507"/>
                 </a:solidFill>
@@ -4811,17 +4811,8 @@
                 <a:ea typeface="Calibri" pitchFamily="34" charset="-122"/>
                 <a:cs typeface="Calibri" pitchFamily="34" charset="-120"/>
               </a:rPr>
-              <a:t>Адресат: студент AlmaU без компании</a:t>
+              <a:t>Адресат: студент AlmaU, которому неловко идти одному</a:t>
             </a:r>
-            <a:endParaRPr lang="en-US" sz="3000" dirty="0"/>
-          </a:p>
-          <a:p>
-            <a:pPr indent="0" marL="0">
-              <a:spcAft>
-                <a:spcPts val="400"/>
-              </a:spcAft>
-              <a:buNone/>
-            </a:pPr>
             <a:endParaRPr lang="en-US" sz="3000" dirty="0"/>
           </a:p>
           <a:p>
@@ -4832,7 +4823,7 @@
               <a:buNone/>
             </a:pPr>
             <a:r>
-              <a:rPr lang="en-US" sz="2000" dirty="0">
+              <a:rPr lang="en-US" sz="1800" dirty="0">
                 <a:solidFill>
                   <a:srgbClr val="050507"/>
                 </a:solidFill>
@@ -4840,17 +4831,8 @@
                 <a:ea typeface="Calibri" pitchFamily="34" charset="-122"/>
                 <a:cs typeface="Calibri" pitchFamily="34" charset="-120"/>
               </a:rPr>
-              <a:t>УТП: одна фраза</a:t>
+              <a:t>УТП: из «не с кем» в «идём вместе»</a:t>
             </a:r>
-            <a:endParaRPr lang="en-US" sz="3000" dirty="0"/>
-          </a:p>
-          <a:p>
-            <a:pPr indent="0" marL="0">
-              <a:spcAft>
-                <a:spcPts val="400"/>
-              </a:spcAft>
-              <a:buNone/>
-            </a:pPr>
             <a:endParaRPr lang="en-US" sz="3000" dirty="0"/>
           </a:p>
           <a:p>
@@ -4861,7 +4843,7 @@
               <a:buNone/>
             </a:pPr>
             <a:r>
-              <a:rPr lang="en-US" sz="2000" dirty="0">
+              <a:rPr lang="en-US" sz="1800" dirty="0">
                 <a:solidFill>
                   <a:srgbClr val="050507"/>
                 </a:solidFill>
@@ -4880,17 +4862,8 @@
               </a:spcAft>
               <a:buNone/>
             </a:pPr>
-            <a:endParaRPr lang="en-US" sz="3000" dirty="0"/>
-          </a:p>
-          <a:p>
-            <a:pPr indent="0" marL="0">
-              <a:spcAft>
-                <a:spcPts val="400"/>
-              </a:spcAft>
-              <a:buNone/>
-            </a:pPr>
             <a:r>
-              <a:rPr lang="en-US" sz="2000" dirty="0">
+              <a:rPr lang="en-US" sz="1800" dirty="0">
                 <a:solidFill>
                   <a:srgbClr val="050507"/>
                 </a:solidFill>

</xml_diff>

<commit_message>
Teaser on mountain background in brand colors; Summit Seekers event template
Co-Authored-By: Claude Sonnet 5.5 <noreply@anthropic.com>
Claude-Session: https://claude.ai/code/session_01MmjQUuUoAAFt56mVbb2Lw5
</commit_message>
<xml_diff>
--- a/docs/Workshop_Almau_Messenger.pptx
+++ b/docs/Workshop_Almau_Messenger.pptx
@@ -681,7 +681,7 @@
           <a:p>
             <a:r>
               <a:rPr lang="en-US" dirty="0"/>
-              <a:t>ХАМИД. Тизер: заголовок «Тебе не с кем идти? Кому-то тоже.» Дальше мини-диалог двух анонимов: «Кто идёт один?» — «Я тоже! Идём вместе?». Призыв один: найти попутчика в боте. На картинке QR-код. Площадка — Instagram и рассылки Summit Seekers: именно оттуда к нам уже пришли 10–15 человек. Результат измеряем по ссылке с меткой.</a:t>
+              <a:t>ХАМИД. Тизер: заголовок «Тебе не с кем идти? Кому-то тоже.» Дальше мини-диалог двух анонимов: «Кто идёт один?» — «Я тоже! Идём вместе?». Призыв один: найти попутчика в боте. На картинке QR-код. Этот шаблон мы будем использовать для всех ивентов Summit Seekers: меняем только название и дату. Площадка — Instagram и рассылки Summit Seekers: именно оттуда к нам уже пришли 10–15 человек. Результат измеряем по ссылке с меткой.</a:t>
             </a:r>
             <a:endParaRPr lang="en-US" dirty="0"/>
           </a:p>
@@ -3411,7 +3411,7 @@
                 <a:ea typeface="Calibri" pitchFamily="34" charset="-122"/>
                 <a:cs typeface="Calibri" pitchFamily="34" charset="-120"/>
               </a:rPr>
-              <a:t>Оттуда уже пришли 10–15 человек</a:t>
+              <a:t>Шаблон для всех ивентов Summit Seekers. Оттуда уже 10–15 человек</a:t>
             </a:r>
             <a:endParaRPr lang="en-US" sz="1600" dirty="0"/>
           </a:p>

</xml_diff>